<commit_message>
docs: deck and README reflect hosted persistence
</commit_message>
<xml_diff>
--- a/docs/Ayush_Gupta_Incoming_Request_Processing_Workflow.pptx
+++ b/docs/Ayush_Gupta_Incoming_Request_Processing_Workflow.pptx
@@ -8390,7 +8390,7 @@
         <p:spPr>
           <a:xfrm>
             <a:off x="640080" y="4406496"/>
-            <a:ext cx="6949440" cy="384048"/>
+            <a:ext cx="6949440" cy="512064"/>
           </a:xfrm>
           <a:prstGeom prst="rect">
             <a:avLst/>
@@ -8417,7 +8417,7 @@
                 <a:ea typeface="Calibri" pitchFamily="34" charset="-122"/>
                 <a:cs typeface="Calibri" pitchFamily="34" charset="-120"/>
               </a:rPr>
-              <a:t>Demo mode opens cold from committed batch data — no keys, no network. Live mode sends a pasted message through the same pipeline, with a provider-outage toggle that degrades on the real code path rather than animating one.</a:t>
+              <a:t>Demo mode opens cold from committed batch data — no keys, no network. Live mode runs a pasted message through the same pipeline, with a provider-outage toggle that degrades on the real code path, and persists every case to libSQL — so a repeat send is caught as a duplicate before any model call.</a:t>
             </a:r>
             <a:endParaRPr lang="en-US" sz="900" dirty="0"/>
           </a:p>
@@ -9049,7 +9049,7 @@
                 <a:ea typeface="Calibri" pitchFamily="34" charset="-122"/>
                 <a:cs typeface="Calibri" pitchFamily="34" charset="-120"/>
               </a:rPr>
-              <a:t>Postgres and queue workers</a:t>
+              <a:t>Queue workers and per-class routing</a:t>
             </a:r>
             <a:endParaRPr lang="en-US" sz="950" dirty="0"/>
           </a:p>
@@ -9069,7 +9069,7 @@
                 <a:ea typeface="Calibri" pitchFamily="34" charset="-122"/>
                 <a:cs typeface="Calibri" pitchFamily="34" charset="-120"/>
               </a:rPr>
-              <a:t>With per-class routing, at ~10k requests a day.</a:t>
+              <a:t>The storage swap is already done: hosted cases persist to libSQL.</a:t>
             </a:r>
             <a:endParaRPr lang="en-US" sz="950" dirty="0"/>
           </a:p>

</xml_diff>